<commit_message>
Update solution presentation with final metrics and details
</commit_message>
<xml_diff>
--- a/solution_presentation.pptx
+++ b/solution_presentation.pptx
@@ -616,7 +616,7 @@
                   <c:v>23.083</c:v>
                 </c:pt>
                 <c:pt idx="1">
-                  <c:v>27.807</c:v>
+                  <c:v>27.81</c:v>
                 </c:pt>
               </c:numCache>
             </c:numRef>
@@ -891,7 +891,7 @@
                   <c:v>0.5545</c:v>
                 </c:pt>
                 <c:pt idx="1">
-                  <c:v>0.768</c:v>
+                  <c:v>0.7678</c:v>
                 </c:pt>
               </c:numCache>
             </c:numRef>
@@ -1166,7 +1166,7 @@
                   <c:v>0.4351</c:v>
                 </c:pt>
                 <c:pt idx="1">
-                  <c:v>0.2696</c:v>
+                  <c:v>0.2706</c:v>
                 </c:pt>
               </c:numCache>
             </c:numRef>
@@ -3267,7 +3267,7 @@
                 <a:ea typeface="Calibri" pitchFamily="34" charset="-122"/>
                 <a:cs typeface="Calibri" pitchFamily="34" charset="-120"/>
               </a:rPr>
-              <a:t>A NAFNet-based joint denoising + super-resolution model that restores NoisyLR images to GT quality — 27.8 dB PSNR, +4.7 dB over a bicubic baseline, at ~5 ms/image on GPU.</a:t>
+              <a:t>A NAFNet-based joint denoising + super-resolution model that restores NoisyLR images to GT quality — 27.8 dB PSNR, +4.7 dB over a bicubic baseline, at ~15 ms/image on GPU.</a:t>
             </a:r>
             <a:endParaRPr lang="en-US" sz="1600" dirty="0"/>
           </a:p>
@@ -3306,7 +3306,7 @@
                 <a:ea typeface="Calibri" pitchFamily="34" charset="-122"/>
                 <a:cs typeface="Calibri" pitchFamily="34" charset="-120"/>
               </a:rPr>
-              <a:t>Team [Your Team Name]</a:t>
+              <a:t>Team Anaavarana · A Trail to Unveil</a:t>
             </a:r>
             <a:endParaRPr lang="en-US" sz="1300" dirty="0"/>
           </a:p>
@@ -3475,7 +3475,7 @@
                 <a:ea typeface="Calibri" pitchFamily="34" charset="-122"/>
                 <a:cs typeface="Calibri" pitchFamily="34" charset="-120"/>
               </a:rPr>
-              <a:t>5.8 ms</a:t>
+              <a:t>15.3 ms</a:t>
             </a:r>
             <a:endParaRPr lang="en-US" sz="2400" dirty="0"/>
           </a:p>
@@ -3603,7 +3603,7 @@
                 <a:ea typeface="Calibri" pitchFamily="34" charset="-122"/>
                 <a:cs typeface="Calibri" pitchFamily="34" charset="-120"/>
               </a:rPr>
-              <a:t>~5 ms</a:t>
+              <a:t>~13.9 ms</a:t>
             </a:r>
             <a:endParaRPr lang="en-US" sz="2400" dirty="0"/>
           </a:p>
@@ -3731,7 +3731,7 @@
                 <a:ea typeface="Calibri" pitchFamily="34" charset="-122"/>
                 <a:cs typeface="Calibri" pitchFamily="34" charset="-120"/>
               </a:rPr>
-              <a:t>400</a:t>
+              <a:t>320</a:t>
             </a:r>
             <a:endParaRPr lang="en-US" sz="2400" dirty="0"/>
           </a:p>
@@ -3859,7 +3859,7 @@
                 <a:ea typeface="Calibri" pitchFamily="34" charset="-122"/>
                 <a:cs typeface="Calibri" pitchFamily="34" charset="-120"/>
               </a:rPr>
-              <a:t>2.34 s</a:t>
+              <a:t>4.90 s</a:t>
             </a:r>
             <a:endParaRPr lang="en-US" sz="2400" dirty="0"/>
           </a:p>
@@ -3921,7 +3921,7 @@
                 <a:ea typeface="Calibri" pitchFamily="34" charset="-122"/>
                 <a:cs typeface="Calibri" pitchFamily="34" charset="-120"/>
               </a:rPr>
-              <a:t>(400 images, batch=8)</a:t>
+              <a:t>(320 images, batch=8)</a:t>
             </a:r>
             <a:endParaRPr lang="en-US" sz="1100" dirty="0"/>
           </a:p>
@@ -5919,7 +5919,7 @@
                 <a:ea typeface="Calibri" pitchFamily="34" charset="-122"/>
                 <a:cs typeface="Calibri" pitchFamily="34" charset="-120"/>
               </a:rPr>
-              <a:t>27.8 dB PSNR / 0.768 SSIM / 0.270 LPIPS on held-out full-resolution validation</a:t>
+              <a:t>27.81 dB PSNR / 0.768 SSIM / 0.271 LPIPS on held-out full-resolution validation</a:t>
             </a:r>
             <a:endParaRPr lang="en-US" sz="1300" dirty="0"/>
           </a:p>
@@ -5967,7 +5967,7 @@
                 <a:ea typeface="Calibri" pitchFamily="34" charset="-122"/>
                 <a:cs typeface="Calibri" pitchFamily="34" charset="-120"/>
               </a:rPr>
-              <a:t>~5 ms/image steady-state inference on a T4 GPU (expect faster on H100)</a:t>
+              <a:t>~14 ms/image steady-state inference on a T4 GPU (expect faster on H100)</a:t>
             </a:r>
             <a:endParaRPr lang="en-US" sz="1300" dirty="0"/>
           </a:p>
@@ -6337,7 +6337,7 @@
                 <a:ea typeface="Calibri" pitchFamily="34" charset="-122"/>
                 <a:cs typeface="Calibri" pitchFamily="34" charset="-120"/>
               </a:rPr>
-              <a:t>[GitHub repository link — insert before submission]</a:t>
+              <a:t>https://github.com/Nag123-tel/kla-restoration</a:t>
             </a:r>
             <a:endParaRPr lang="en-US" sz="1250" dirty="0"/>
           </a:p>
@@ -12277,7 +12277,7 @@
                 <a:ea typeface="Calibri" pitchFamily="34" charset="-122"/>
                 <a:cs typeface="Calibri" pitchFamily="34" charset="-120"/>
               </a:rPr>
-              <a:t>+4.72 dB vs baseline</a:t>
+              <a:t>+4.73 dB vs baseline</a:t>
             </a:r>
             <a:endParaRPr lang="en-US" sz="1250" dirty="0"/>
           </a:p>
@@ -12441,7 +12441,7 @@
                 <a:ea typeface="Calibri" pitchFamily="34" charset="-122"/>
                 <a:cs typeface="Calibri" pitchFamily="34" charset="-120"/>
               </a:rPr>
-              <a:t>−0.166 vs baseline</a:t>
+              <a:t>−0.164 vs baseline</a:t>
             </a:r>
             <a:endParaRPr lang="en-US" sz="1250" dirty="0"/>
           </a:p>

</xml_diff>

<commit_message>
Fix Slide 6: remove in-progress/benchmarked contradiction on small variant
</commit_message>
<xml_diff>
--- a/solution_presentation.pptx
+++ b/solution_presentation.pptx
@@ -10247,7 +10247,7 @@
                 <a:ea typeface="Calibri" pitchFamily="34" charset="-122"/>
                 <a:cs typeface="Calibri" pitchFamily="34" charset="-120"/>
               </a:rPr>
-              <a:t>small  (in progress)</a:t>
+              <a:t>small</a:t>
             </a:r>
             <a:endParaRPr lang="en-US" sz="1300" dirty="0"/>
           </a:p>
@@ -10328,7 +10328,7 @@
                 <a:ea typeface="Calibri" pitchFamily="34" charset="-122"/>
                 <a:cs typeface="Calibri" pitchFamily="34" charset="-120"/>
               </a:rPr>
-              <a:t>No fixed parameter-count limit per KLA spec — tiny chosen as the primary submission for its strong quality/throughput trade-off; small benchmarked as a comparison point.</a:t>
+              <a:t>No fixed parameter-count limit per KLA spec — tiny chosen as the primary submission for its strong quality/throughput trade-off. small was also trained (see Slide 8) but not formally benchmarked against the held-out validation set; that comparison is listed under Next Steps.</a:t>
             </a:r>
             <a:endParaRPr lang="en-US" sz="1200" dirty="0"/>
           </a:p>

</xml_diff>